<commit_message>
Week 4 Monday: decks, board work and cheat sheet carry the cold-read fixes
S1 defines the top-up, gaming, bookings and the outer zones; the board asks
how the number could rise while riders were served no better; S19's pair
pulls the way the city does; the tree, the seesaw and the definition carry
three guardrails, two for riders and one for the budget; S43 and S47 quote
and gloss what they cite. The board work copies every deck drawing, and
the cheat sheet prints on one page with its vocabulary strip. All three
decks are rebuilt and render with no overflow.

Co-Authored-By: Claude Opus 5.5 <noreply@anthropic.com>
Claude-Session: https://claude.ai/code/session_01E6fToBsfuBoCSExpM8sbja
</commit_message>
<xml_diff>
--- a/content/W04/D1/slides/C2_W04_D01_fallback_STUDENT.pptx
+++ b/content/W04/D1/slides/C2_W04_D01_fallback_STUDENT.pptx
@@ -7044,7 +7044,7 @@
                 </a:solidFill>
                 <a:latin typeface="Calibri"/>
               </a:rPr>
-              <a:t>How does a candidate get three teams who each want their own target to one number, and what do they say to the two who lose?</a:t>
+              <a:t>How does a candidate get three teams who each want their own target to one number, and what do they say to the teams who lose?</a:t>
             </a:r>
           </a:p>
         </p:txBody>
@@ -7590,7 +7590,7 @@
         </p:nvGraphicFramePr>
         <p:xfrm>
           <a:off x="530352" y="1956816"/>
-          <a:ext cx="11130989" cy="2816352"/>
+          <a:ext cx="11130989" cy="3058160"/>
         </p:xfrm>
         <a:graphic>
           <a:graphicData uri="http://schemas.openxmlformats.org/drawingml/2006/table">
@@ -7807,7 +7807,7 @@
                   </a:tcPr>
                 </a:tc>
               </a:tr>
-              <a:tr h="611632">
+              <a:tr h="853440">
                 <a:tc>
                   <a:txBody>
                     <a:bodyPr/>
@@ -7820,7 +7820,7 @@
                           </a:solidFill>
                           <a:latin typeface="Calibri"/>
                         </a:rPr>
-                        <a:t>The two who lose</a:t>
+                        <a:t>The teams who lose</a:t>
                       </a:r>
                     </a:p>
                   </a:txBody>
@@ -7864,7 +7864,7 @@
                           </a:solidFill>
                           <a:latin typeface="Calibri"/>
                         </a:rPr>
-                        <a:t>Shows where their number now lives: hours as an input beside trips per hour, top-up per trip as a guardrail</a:t>
+                        <a:t>Says none of the three numbers is the target, then places each: hours beside trips per online hour; the enrolled count beside the rate; a total cap and cost per extra trip for finance</a:t>
                       </a:r>
                     </a:p>
                   </a:txBody>
@@ -7932,7 +7932,7 @@
                           </a:solidFill>
                           <a:latin typeface="Calibri"/>
                         </a:rPr>
-                        <a:t>"If waits rose while the north star held, I would revisit the floor"</a:t>
+                        <a:t>"If the wait by zone rose under the new rule, I would revisit the acceptance floor"</a:t>
                       </a:r>
                     </a:p>
                   </a:txBody>
@@ -9301,7 +9301,7 @@
         <p:spPr>
           <a:xfrm>
             <a:off x="530352" y="1956816"/>
-            <a:ext cx="2079894" cy="2534412"/>
+            <a:ext cx="2079894" cy="2724404"/>
           </a:xfrm>
           <a:prstGeom prst="roundRect">
             <a:avLst>
@@ -9528,7 +9528,7 @@
         <p:spPr>
           <a:xfrm>
             <a:off x="2793126" y="1956816"/>
-            <a:ext cx="2079894" cy="2534412"/>
+            <a:ext cx="2079894" cy="2724404"/>
           </a:xfrm>
           <a:prstGeom prst="roundRect">
             <a:avLst>
@@ -9720,7 +9720,7 @@
         <p:spPr>
           <a:xfrm>
             <a:off x="2994294" y="3303524"/>
-            <a:ext cx="1677558" cy="763016"/>
+            <a:ext cx="1677558" cy="944626"/>
           </a:xfrm>
           <a:prstGeom prst="rect">
             <a:avLst/>
@@ -9741,7 +9741,7 @@
                 </a:solidFill>
                 <a:latin typeface="Calibri"/>
               </a:rPr>
-              <a:t>A debit card, the largest product, could sit unused in the count for up to four years</a:t>
+              <a:t>A debit card, the largest product category, could stay in the count for up to four years with no use</a:t>
             </a:r>
           </a:p>
         </p:txBody>
@@ -9755,7 +9755,7 @@
         <p:spPr>
           <a:xfrm>
             <a:off x="5055900" y="1956816"/>
-            <a:ext cx="2079894" cy="2534412"/>
+            <a:ext cx="2079894" cy="2724404"/>
           </a:xfrm>
           <a:prstGeom prst="roundRect">
             <a:avLst>
@@ -9947,7 +9947,7 @@
         <p:spPr>
           <a:xfrm>
             <a:off x="5257068" y="3303524"/>
-            <a:ext cx="1677558" cy="944626"/>
+            <a:ext cx="1677558" cy="1126236"/>
           </a:xfrm>
           <a:prstGeom prst="rect">
             <a:avLst/>
@@ -9968,7 +9968,7 @@
                 </a:solidFill>
                 <a:latin typeface="Calibri"/>
               </a:rPr>
-              <a:t>In 2013 remittance accounts were added without telling investors; 0.04 of that year's 0.11 rise</a:t>
+              <a:t>In 2013 remittance accounts joined the count without investors being told, giving 0.04 of that year's 0.11 rise in the ratio</a:t>
             </a:r>
           </a:p>
         </p:txBody>
@@ -9982,7 +9982,7 @@
         <p:spPr>
           <a:xfrm>
             <a:off x="7318674" y="1956816"/>
-            <a:ext cx="2079894" cy="2534412"/>
+            <a:ext cx="2079894" cy="2724404"/>
           </a:xfrm>
           <a:prstGeom prst="roundRect">
             <a:avLst>
@@ -10174,7 +10174,7 @@
         <p:spPr>
           <a:xfrm>
             <a:off x="7519842" y="3303524"/>
-            <a:ext cx="1677558" cy="763016"/>
+            <a:ext cx="1677558" cy="944626"/>
           </a:xfrm>
           <a:prstGeom prst="rect">
             <a:avLst/>
@@ -10195,7 +10195,7 @@
                 </a:solidFill>
                 <a:latin typeface="Calibri"/>
               </a:rPr>
-              <a:t>Staff moved customers' money into new accounts to meet the funding rule for sales credit</a:t>
+              <a:t>Staff moved customers' money into new accounts so the accounts counted as funded and earned sales credit</a:t>
             </a:r>
           </a:p>
         </p:txBody>
@@ -10209,7 +10209,7 @@
         <p:spPr>
           <a:xfrm>
             <a:off x="9581448" y="1956816"/>
-            <a:ext cx="2079894" cy="2534412"/>
+            <a:ext cx="2079894" cy="2724404"/>
           </a:xfrm>
           <a:prstGeom prst="roundRect">
             <a:avLst>
@@ -10435,7 +10435,7 @@
         </p:nvSpPr>
         <p:spPr>
           <a:xfrm>
-            <a:off x="530352" y="4674108"/>
+            <a:off x="530352" y="4864100"/>
             <a:ext cx="11130991" cy="495807"/>
           </a:xfrm>
           <a:prstGeom prst="rect">
@@ -11384,7 +11384,7 @@
                 </a:solidFill>
                 <a:latin typeface="Calibri"/>
               </a:rPr>
-              <a:t>a) Numerator: count only accounts the customer used</a:t>
+              <a:t>a) Numerator: count an account only if the customer used it</a:t>
             </a:r>
           </a:p>
           <a:p>
@@ -11416,7 +11416,7 @@
                 </a:solidFill>
                 <a:latin typeface="Calibri"/>
               </a:rPr>
-              <a:t>c) Window: an account counts only if used inside the period</a:t>
+              <a:t>c) Window: drop an account once it goes unused for the period</a:t>
             </a:r>
           </a:p>
           <a:p>
@@ -13726,7 +13726,7 @@
         <p:spPr>
           <a:xfrm>
             <a:off x="530352" y="1956816"/>
-            <a:ext cx="3588410" cy="1964436"/>
+            <a:ext cx="3588410" cy="2154428"/>
           </a:xfrm>
           <a:prstGeom prst="roundRect">
             <a:avLst>
@@ -13953,7 +13953,7 @@
         <p:spPr>
           <a:xfrm>
             <a:off x="4301642" y="1956816"/>
-            <a:ext cx="3588410" cy="1964436"/>
+            <a:ext cx="3588410" cy="2154428"/>
           </a:xfrm>
           <a:prstGeom prst="roundRect">
             <a:avLst>
@@ -14044,7 +14044,7 @@
       </p:sp>
       <p:pic>
         <p:nvPicPr>
-          <p:cNvPr id="17" name="Picture 16" descr="map-pin_d669bc82d623.png"/>
+          <p:cNvPr id="17" name="Picture 16" descr="wallet_3a2d2f5ade12.png"/>
           <p:cNvPicPr>
             <a:picLocks noChangeAspect="1"/>
           </p:cNvPicPr>
@@ -14096,7 +14096,7 @@
                 </a:solidFill>
                 <a:latin typeface="Calibri"/>
               </a:rPr>
-              <a:t>CITY HEAD</a:t>
+              <a:t>FINANCE PARTNER</a:t>
             </a:r>
           </a:p>
         </p:txBody>
@@ -14145,7 +14145,7 @@
         <p:spPr>
           <a:xfrm>
             <a:off x="4502810" y="3303524"/>
-            <a:ext cx="3186074" cy="399796"/>
+            <a:ext cx="3186074" cy="581406"/>
           </a:xfrm>
           <a:prstGeom prst="rect">
             <a:avLst/>
@@ -14166,7 +14166,7 @@
                 </a:solidFill>
                 <a:latin typeface="Calibri"/>
               </a:rPr>
-              <a:t>Rewards trips, including the short ones a driver cherry-picks</a:t>
+              <a:t>Rewards trips, including the short ones a driver cherry-picks; finance wants each rupee to buy a trip</a:t>
             </a:r>
           </a:p>
         </p:txBody>
@@ -14180,7 +14180,7 @@
         <p:spPr>
           <a:xfrm>
             <a:off x="8072932" y="1956816"/>
-            <a:ext cx="3588410" cy="1964436"/>
+            <a:ext cx="3588410" cy="2154428"/>
           </a:xfrm>
           <a:prstGeom prst="roundRect">
             <a:avLst>
@@ -14271,7 +14271,7 @@
       </p:sp>
       <p:pic>
         <p:nvPicPr>
-          <p:cNvPr id="23" name="Picture 22" descr="wallet_3a2d2f5ade12.png"/>
+          <p:cNvPr id="23" name="Picture 22" descr="megaphone_df6318bcf2f9.png"/>
           <p:cNvPicPr>
             <a:picLocks noChangeAspect="1"/>
           </p:cNvPicPr>
@@ -14323,7 +14323,7 @@
                 </a:solidFill>
                 <a:latin typeface="Calibri"/>
               </a:rPr>
-              <a:t>FINANCE PARTNER</a:t>
+              <a:t>MARKETING LEAD</a:t>
             </a:r>
           </a:p>
         </p:txBody>
@@ -14358,7 +14358,7 @@
                 </a:solidFill>
                 <a:latin typeface="Calibri"/>
               </a:rPr>
-              <a:t>Acceptance share</a:t>
+              <a:t>Share of offers accepted</a:t>
             </a:r>
           </a:p>
         </p:txBody>
@@ -14372,7 +14372,7 @@
         <p:spPr>
           <a:xfrm>
             <a:off x="8274100" y="3303524"/>
-            <a:ext cx="3186074" cy="399796"/>
+            <a:ext cx="3186074" cy="581406"/>
           </a:xfrm>
           <a:prstGeom prst="rect">
             <a:avLst/>
@@ -14393,7 +14393,7 @@
                 </a:solidFill>
                 <a:latin typeface="Calibri"/>
               </a:rPr>
-              <a:t>Rewards saying yes, including to trips later cancelled</a:t>
+              <a:t>Rewards saying yes, including to trips later cancelled; the number marketing can show riders</a:t>
             </a:r>
           </a:p>
         </p:txBody>
@@ -14406,7 +14406,7 @@
         </p:nvSpPr>
         <p:spPr>
           <a:xfrm>
-            <a:off x="530352" y="4104132"/>
+            <a:off x="530352" y="4294124"/>
             <a:ext cx="11130991" cy="772160"/>
           </a:xfrm>
           <a:prstGeom prst="rect">
@@ -15039,7 +15039,7 @@
         </p:nvGraphicFramePr>
         <p:xfrm>
           <a:off x="530352" y="1956816"/>
-          <a:ext cx="11130989" cy="1962912"/>
+          <a:ext cx="11130990" cy="1962912"/>
         </p:xfrm>
         <a:graphic>
           <a:graphicData uri="http://schemas.openxmlformats.org/drawingml/2006/table">
@@ -15048,10 +15048,10 @@
                 <a:tableStyleId>{2D5ABB26-0587-4C30-8999-92F81FD0307C}</a:tableStyleId>
               </a:tblPr>
               <a:tblGrid>
-                <a:gridCol w="1250210"/>
-                <a:gridCol w="3398922"/>
-                <a:gridCol w="2324566"/>
-                <a:gridCol w="4157291"/>
+                <a:gridCol w="1217140"/>
+                <a:gridCol w="3309015"/>
+                <a:gridCol w="2263078"/>
+                <a:gridCol w="4341757"/>
               </a:tblGrid>
               <a:tr h="335280">
                 <a:tc>
@@ -15246,7 +15246,7 @@
                           </a:solidFill>
                           <a:latin typeface="Calibri"/>
                         </a:rPr>
-                        <a:t>City head</a:t>
+                        <a:t>Finance partner</a:t>
                       </a:r>
                     </a:p>
                   </a:txBody>
@@ -15268,7 +15268,7 @@
                           </a:solidFill>
                           <a:latin typeface="Calibri"/>
                         </a:rPr>
-                        <a:t>"Trips are the outcome; why guard them?"</a:t>
+                        <a:t>"Trips are what the money buys; why guard them?"</a:t>
                       </a:r>
                     </a:p>
                   </a:txBody>
@@ -15336,7 +15336,7 @@
                           </a:solidFill>
                           <a:latin typeface="Calibri"/>
                         </a:rPr>
-                        <a:t>Finance partner</a:t>
+                        <a:t>Marketing lead</a:t>
                       </a:r>
                     </a:p>
                   </a:txBody>
@@ -15358,7 +15358,7 @@
                           </a:solidFill>
                           <a:latin typeface="Calibri"/>
                         </a:rPr>
-                        <a:t>"Acceptance is the cheapest number to check"</a:t>
+                        <a:t>"Acceptance is what riders feel first"</a:t>
                       </a:r>
                     </a:p>
                   </a:txBody>
@@ -15402,7 +15402,7 @@
                           </a:solidFill>
                           <a:latin typeface="Calibri"/>
                         </a:rPr>
-                        <a:t>Gaming note: an accepted trip then cancelled; cancels beside it</a:t>
+                        <a:t>Gaming note: an accepted trip then cancelled; the cancel share beside it</a:t>
                       </a:r>
                     </a:p>
                   </a:txBody>

</xml_diff>

<commit_message>
W04 D1: half one opens on the six subtopics as concept chapters, then the Uber case, renumbered
The deck opens on the day's topic, the week map, the topics slide and the
concept map, then the ticket as the destination. Six concept chapters follow,
one per row subtopic in the row's order, each on an invented example counted by
hand, with its picture, code glimpse, rules and map node. The case chapters
become SECTIONs 7 to 11, each naming the subtopics it applies; the canteen,
Wells Fargo, Swiggy, Delhi Metro, the lead picture, the VA clock and Maxxsaver
with Eternal moved into the concept chapters and leave a recall by name. A small
script renumbers the slides and prints where every old slide went; the fallback
deck's sections become 13 to 16.

Co-Authored-By: Claude Opus 5.5 <noreply@anthropic.com>
Claude-Session: https://claude.ai/code/session_01PKfnG4dDHtQtNuxCao8MwS
</commit_message>
<xml_diff>
--- a/content/W04/D1/slides/C2_W04_D01_fallback_STUDENT.pptx
+++ b/content/W04/D1/slides/C2_W04_D01_fallback_STUDENT.pptx
@@ -1170,7 +1170,7 @@
           </a:p>
           <a:p>
             <a:r>
-              <a:t>and VA's desired date from the morning), a definition change in Uber's own count (none in the case;</a:t>
+              <a:t>and VA's desired date from chapter 5), a definition change in Uber's own count (none in the case;</a:t>
             </a:r>
           </a:p>
           <a:p>
@@ -4764,7 +4764,7 @@
                 </a:solidFill>
                 <a:latin typeface="Georgia"/>
               </a:rPr>
-              <a:t>06</a:t>
+              <a:t>13</a:t>
             </a:r>
           </a:p>
         </p:txBody>
@@ -5295,7 +5295,7 @@
                 </a:solidFill>
                 <a:latin typeface="Calibri"/>
               </a:rPr>
-              <a:t>WEEK 4  ·  DAY 1  ·  THE METRIC CLINIC, IF THE TENTATIVE FACULTY BLOCK SLIPS</a:t>
+              <a:t>WEEK 4  ·  MONDAY  ·  THE METRIC CLINIC, IF THE TENTATIVE FACULTY BLOCK SLIPS</a:t>
             </a:r>
           </a:p>
         </p:txBody>
@@ -6048,7 +6048,7 @@
                 </a:solidFill>
                 <a:latin typeface="Calibri"/>
               </a:rPr>
-              <a:t>WEEK 4  ·  DAY 1  ·  THE METRIC CLINIC, IF THE TENTATIVE FACULTY BLOCK SLIPS</a:t>
+              <a:t>WEEK 4  ·  MONDAY  ·  THE METRIC CLINIC, IF THE TENTATIVE FACULTY BLOCK SLIPS</a:t>
             </a:r>
           </a:p>
         </p:txBody>
@@ -6974,7 +6974,7 @@
                 </a:solidFill>
                 <a:latin typeface="Georgia"/>
               </a:rPr>
-              <a:t>09</a:t>
+              <a:t>16</a:t>
             </a:r>
           </a:p>
         </p:txBody>
@@ -7505,7 +7505,7 @@
                 </a:solidFill>
                 <a:latin typeface="Calibri"/>
               </a:rPr>
-              <a:t>WEEK 4  ·  DAY 1  ·  THE METRIC CLINIC, IF THE TENTATIVE FACULTY BLOCK SLIPS</a:t>
+              <a:t>WEEK 4  ·  MONDAY  ·  THE METRIC CLINIC, IF THE TENTATIVE FACULTY BLOCK SLIPS</a:t>
             </a:r>
           </a:p>
         </p:txBody>
@@ -8464,7 +8464,7 @@
                 </a:solidFill>
                 <a:latin typeface="Calibri"/>
               </a:rPr>
-              <a:t>WEEK 4  ·  DAY 1  ·  THE METRIC CLINIC, IF THE TENTATIVE FACULTY BLOCK SLIPS</a:t>
+              <a:t>WEEK 4  ·  MONDAY  ·  THE METRIC CLINIC, IF THE TENTATIVE FACULTY BLOCK SLIPS</a:t>
             </a:r>
           </a:p>
         </p:txBody>
@@ -9217,7 +9217,7 @@
                 </a:solidFill>
                 <a:latin typeface="Calibri"/>
               </a:rPr>
-              <a:t>WEEK 4  ·  DAY 1  ·  THE METRIC CLINIC, IF THE TENTATIVE FACULTY BLOCK SLIPS</a:t>
+              <a:t>WEEK 4  ·  MONDAY  ·  THE METRIC CLINIC, IF THE TENTATIVE FACULTY BLOCK SLIPS</a:t>
             </a:r>
           </a:p>
         </p:txBody>
@@ -10983,7 +10983,7 @@
                 </a:solidFill>
                 <a:latin typeface="Calibri"/>
               </a:rPr>
-              <a:t>WEEK 4  ·  DAY 1  ·  THE METRIC CLINIC, IF THE TENTATIVE FACULTY BLOCK SLIPS</a:t>
+              <a:t>WEEK 4  ·  MONDAY  ·  THE METRIC CLINIC, IF THE TENTATIVE FACULTY BLOCK SLIPS</a:t>
             </a:r>
           </a:p>
         </p:txBody>
@@ -11986,7 +11986,7 @@
                 </a:solidFill>
                 <a:latin typeface="Calibri"/>
               </a:rPr>
-              <a:t>WEEK 4  ·  DAY 1  ·  THE METRIC CLINIC, IF THE TENTATIVE FACULTY BLOCK SLIPS</a:t>
+              <a:t>WEEK 4  ·  MONDAY  ·  THE METRIC CLINIC, IF THE TENTATIVE FACULTY BLOCK SLIPS</a:t>
             </a:r>
           </a:p>
         </p:txBody>
@@ -13111,7 +13111,7 @@
                 </a:solidFill>
                 <a:latin typeface="Georgia"/>
               </a:rPr>
-              <a:t>07</a:t>
+              <a:t>14</a:t>
             </a:r>
           </a:p>
         </p:txBody>
@@ -13642,7 +13642,7 @@
                 </a:solidFill>
                 <a:latin typeface="Calibri"/>
               </a:rPr>
-              <a:t>WEEK 4  ·  DAY 1  ·  THE METRIC CLINIC, IF THE TENTATIVE FACULTY BLOCK SLIPS</a:t>
+              <a:t>WEEK 4  ·  MONDAY  ·  THE METRIC CLINIC, IF THE TENTATIVE FACULTY BLOCK SLIPS</a:t>
             </a:r>
           </a:p>
         </p:txBody>
@@ -14954,7 +14954,7 @@
                 </a:solidFill>
                 <a:latin typeface="Calibri"/>
               </a:rPr>
-              <a:t>WEEK 4  ·  DAY 1  ·  THE METRIC CLINIC, IF THE TENTATIVE FACULTY BLOCK SLIPS</a:t>
+              <a:t>WEEK 4  ·  MONDAY  ·  THE METRIC CLINIC, IF THE TENTATIVE FACULTY BLOCK SLIPS</a:t>
             </a:r>
           </a:p>
         </p:txBody>
@@ -16008,7 +16008,7 @@
                 </a:solidFill>
                 <a:latin typeface="Georgia"/>
               </a:rPr>
-              <a:t>08</a:t>
+              <a:t>15</a:t>
             </a:r>
           </a:p>
         </p:txBody>
@@ -16539,7 +16539,7 @@
                 </a:solidFill>
                 <a:latin typeface="Calibri"/>
               </a:rPr>
-              <a:t>WEEK 4  ·  DAY 1  ·  THE METRIC CLINIC, IF THE TENTATIVE FACULTY BLOCK SLIPS</a:t>
+              <a:t>WEEK 4  ·  MONDAY  ·  THE METRIC CLINIC, IF THE TENTATIVE FACULTY BLOCK SLIPS</a:t>
             </a:r>
           </a:p>
         </p:txBody>

</xml_diff>

<commit_message>
W04 D1: every leading-and-lagging item reads one week, so the window words no longer give the key away
The concept set's eight Kalpa numbers, the lead-and-lag handout's eight city numbers, the clinic's
S6 and Kahoot Q2 now all read the same week; the call turns on whether a number moves before the
week's orders or trips are counted. Keys and letters are unchanged.

Co-Authored-By: Claude Opus 5.5 <noreply@anthropic.com>
Claude-Session: https://claude.ai/code/session_01PKfnG4dDHtQtNuxCao8MwS
</commit_message>
<xml_diff>
--- a/content/W04/D1/slides/C2_W04_D01_fallback_STUDENT.pptx
+++ b/content/W04/D1/slides/C2_W04_D01_fallback_STUDENT.pptx
@@ -600,7 +600,7 @@
           <a:lstStyle/>
           <a:p>
             <a:r>
-              <a:t>LIVE, 4 minutes. A dashboard of only lagging numbers lets a drift run for weeks before anyone sees</a:t>
+              <a:t>LIVE, 6 minutes. A dashboard of only lagging numbers lets a drift run for weeks before anyone sees</a:t>
             </a:r>
           </a:p>
           <a:p>
@@ -685,7 +685,7 @@
           </a:p>
           <a:p>
             <a:r>
-              <a:t>gaming it catches. A guardrail that is another growth count gets the question: what would it catch?</a:t>
+              <a:t>gaming it catches. A growth target offered as a guardrail gets the question: what would it catch?</a:t>
             </a:r>
           </a:p>
           <a:p>
@@ -760,7 +760,7 @@
           <a:lstStyle/>
           <a:p>
             <a:r>
-              <a:t>LIVE, 15 minutes: the second transcript read in pairs (10), scored (5). The transcript is the [D]</a:t>
+              <a:t>LIVE, 15 minutes: the second transcript read in pairs (8), scored (5), the close (2). The transcript is the [D]</a:t>
             </a:r>
           </a:p>
           <a:p>
@@ -840,7 +840,12 @@
           <a:lstStyle/>
           <a:p>
             <a:r>
-              <a:t>LIVE, 8 minutes. Score both on the scorecard (trainer/C2_W04_D01_interview_scorecards_TRAINER.md).</a:t>
+              <a:t>LIVE, 13 minutes: read in pairs (8), then score both on the scorecard (5)</a:t>
+            </a:r>
+          </a:p>
+          <a:p>
+            <a:r>
+              <a:t>(trainer/C2_W04_D01_interview_scorecards_TRAINER.md).</a:t>
             </a:r>
           </a:p>
           <a:p>
@@ -1335,7 +1340,17 @@
           </a:p>
           <a:p>
             <a:r>
-              <a:t>minutes to write.</a:t>
+              <a:t>minutes to write. The finance and marketing readers argue different numbers here than on their round 1</a:t>
+            </a:r>
+          </a:p>
+          <a:p>
+            <a:r>
+              <a:t>cards, on purpose: each defends a number it did not choose, so the room hears each attack from the</a:t>
+            </a:r>
+          </a:p>
+          <a:p>
+            <a:r>
+              <a:t>other side.</a:t>
             </a:r>
           </a:p>
           <a:p>
@@ -1570,7 +1585,17 @@
           <a:lstStyle/>
           <a:p>
             <a:r>
-              <a:t>LIVE, 8 minutes. Letters first, then each group defends two of its calls aloud.</a:t>
+              <a:t>LIVE, 12 minutes. The eight numbers and the options are the handout's Q1, in its order</a:t>
+            </a:r>
+          </a:p>
+          <a:p>
+            <a:r>
+              <a:t>(exercises/unguided/C2_W04_D01_lead_lag_STUDENT.md); its Q2 is the defence. Letters first, then</a:t>
+            </a:r>
+          </a:p>
+          <a:p>
+            <a:r>
+              <a:t>each group defends two of its calls aloud.</a:t>
             </a:r>
           </a:p>
           <a:p>
@@ -5372,7 +5397,7 @@
       </p:sp>
       <p:pic>
         <p:nvPicPr>
-          <p:cNvPr id="9" name="mermaid diagram" descr="fe10c663b620d6a0.png"/>
+          <p:cNvPr id="9" name="mermaid diagram" descr="caebcc638b2de61c.png"/>
           <p:cNvPicPr>
             <a:picLocks noChangeAspect="1"/>
           </p:cNvPicPr>
@@ -5386,8 +5411,8 @@
         </p:blipFill>
         <p:spPr>
           <a:xfrm>
-            <a:off x="1623860" y="1956816"/>
-            <a:ext cx="8943975" cy="1871662"/>
+            <a:off x="1352397" y="1956816"/>
+            <a:ext cx="9486900" cy="1871662"/>
           </a:xfrm>
           <a:prstGeom prst="rect">
             <a:avLst/>
@@ -6271,7 +6296,7 @@
                           </a:solidFill>
                           <a:latin typeface="Calibri"/>
                         </a:rPr>
-                        <a:t>Share of offers accepted, at or above a floor</a:t>
+                        <a:t>Share of offers accepted, at or above an acceptance floor</a:t>
                       </a:r>
                     </a:p>
                   </a:txBody>
@@ -6317,7 +6342,7 @@
                           </a:solidFill>
                           <a:latin typeface="Calibri"/>
                         </a:rPr>
-                        <a:t>Drivers sit online in zones with no riders</a:t>
+                        <a:t>Drivers sit online in zones with few riders</a:t>
                       </a:r>
                     </a:p>
                   </a:txBody>
@@ -16717,7 +16742,7 @@
                           </a:solidFill>
                           <a:latin typeface="Calibri"/>
                         </a:rPr>
-                        <a:t>Enrolled drivers online in the first peak hour</a:t>
+                        <a:t>Rider rating at month end</a:t>
                       </a:r>
                     </a:p>
                   </a:txBody>
@@ -16763,7 +16788,7 @@
                           </a:solidFill>
                           <a:latin typeface="Calibri"/>
                         </a:rPr>
-                        <a:t>Rider requests per online hour, by zone</a:t>
+                        <a:t>Share of offers accepted this week</a:t>
                       </a:r>
                     </a:p>
                   </a:txBody>
@@ -16809,7 +16834,7 @@
                           </a:solidFill>
                           <a:latin typeface="Calibri"/>
                         </a:rPr>
-                        <a:t>Share of offers accepted this week</a:t>
+                        <a:t>Gross bookings for the quarter</a:t>
                       </a:r>
                     </a:p>
                   </a:txBody>
@@ -16855,7 +16880,7 @@
                           </a:solidFill>
                           <a:latin typeface="Calibri"/>
                         </a:rPr>
-                        <a:t>New driver sign-ups this week</a:t>
+                        <a:t>Enrolled drivers online in the first peak hour</a:t>
                       </a:r>
                     </a:p>
                   </a:txBody>
@@ -16947,7 +16972,7 @@
                           </a:solidFill>
                           <a:latin typeface="Calibri"/>
                         </a:rPr>
-                        <a:t>Rider rating at month end</a:t>
+                        <a:t>New driver sign-ups this week</a:t>
                       </a:r>
                     </a:p>
                   </a:txBody>
@@ -16993,7 +17018,7 @@
                           </a:solidFill>
                           <a:latin typeface="Calibri"/>
                         </a:rPr>
-                        <a:t>Drivers who left the platform next quarter</a:t>
+                        <a:t>Drivers who left the platform the next quarter</a:t>
                       </a:r>
                     </a:p>
                   </a:txBody>
@@ -17039,7 +17064,7 @@
                           </a:solidFill>
                           <a:latin typeface="Calibri"/>
                         </a:rPr>
-                        <a:t>Gross bookings for the quarter</a:t>
+                        <a:t>Rider requests per online hour, by zone</a:t>
                       </a:r>
                     </a:p>
                   </a:txBody>
@@ -17088,7 +17113,7 @@
                 </a:solidFill>
                 <a:latin typeface="Calibri"/>
               </a:rPr>
-              <a:t>a) 1, 2, 3 and 4 lead; 5, 6, 7 and 8 lag</a:t>
+              <a:t>a) 2, 4, 6 and 8 lead; the other four lag</a:t>
             </a:r>
           </a:p>
           <a:p>
@@ -17104,7 +17129,7 @@
                 </a:solidFill>
                 <a:latin typeface="Calibri"/>
               </a:rPr>
-              <a:t>b) 1, 3, 5 and 7 lead; 2, 4, 6 and 8 lag</a:t>
+              <a:t>b) 1, 2, 4 and 8 lead; the other four lag</a:t>
             </a:r>
           </a:p>
           <a:p>
@@ -17120,7 +17145,7 @@
                 </a:solidFill>
                 <a:latin typeface="Calibri"/>
               </a:rPr>
-              <a:t>c) 1 and 2 lead; the other six lag</a:t>
+              <a:t>c) 2, 4 and 8 lead; the other five lag</a:t>
             </a:r>
           </a:p>
           <a:p>
@@ -17136,7 +17161,7 @@
                 </a:solidFill>
                 <a:latin typeface="Calibri"/>
               </a:rPr>
-              <a:t>d) 3, 5 and 8 lead; the other five lag</a:t>
+              <a:t>d) 2, 3, 5 and 6 lead; the other four lag</a:t>
             </a:r>
           </a:p>
         </p:txBody>

</xml_diff>

<commit_message>
W04 D1: the three decks rebuilt from their markdown
Co-Authored-By: Claude Opus 5.5 <noreply@anthropic.com>
Claude-Session: https://claude.ai/code/session_01PKfnG4dDHtQtNuxCao8MwS
</commit_message>
<xml_diff>
--- a/content/W04/D1/slides/C2_W04_D01_fallback_STUDENT.pptx
+++ b/content/W04/D1/slides/C2_W04_D01_fallback_STUDENT.pptx
@@ -5397,7 +5397,7 @@
       </p:sp>
       <p:pic>
         <p:nvPicPr>
-          <p:cNvPr id="9" name="mermaid diagram" descr="caebcc638b2de61c.png"/>
+          <p:cNvPr id="9" name="mermaid diagram" descr="c2d06599c11bc324.png"/>
           <p:cNvPicPr>
             <a:picLocks noChangeAspect="1"/>
           </p:cNvPicPr>
@@ -16742,7 +16742,7 @@
                           </a:solidFill>
                           <a:latin typeface="Calibri"/>
                         </a:rPr>
-                        <a:t>Rider rating at month end</a:t>
+                        <a:t>Rider rating of this week's trips</a:t>
                       </a:r>
                     </a:p>
                   </a:txBody>
@@ -16834,7 +16834,7 @@
                           </a:solidFill>
                           <a:latin typeface="Calibri"/>
                         </a:rPr>
-                        <a:t>Gross bookings for the quarter</a:t>
+                        <a:t>Gross bookings this week</a:t>
                       </a:r>
                     </a:p>
                   </a:txBody>
@@ -16880,7 +16880,7 @@
                           </a:solidFill>
                           <a:latin typeface="Calibri"/>
                         </a:rPr>
-                        <a:t>Enrolled drivers online in the first peak hour</a:t>
+                        <a:t>Enrolled drivers online in this week's first peak hours</a:t>
                       </a:r>
                     </a:p>
                   </a:txBody>
@@ -16926,7 +16926,7 @@
                           </a:solidFill>
                           <a:latin typeface="Calibri"/>
                         </a:rPr>
-                        <a:t>Top-up paid for the month</a:t>
+                        <a:t>Top-up paid for this week</a:t>
                       </a:r>
                     </a:p>
                   </a:txBody>
@@ -17018,7 +17018,7 @@
                           </a:solidFill>
                           <a:latin typeface="Calibri"/>
                         </a:rPr>
-                        <a:t>Drivers who left the platform the next quarter</a:t>
+                        <a:t>Rider complaints filed about this week's trips</a:t>
                       </a:r>
                     </a:p>
                   </a:txBody>
@@ -17064,7 +17064,7 @@
                           </a:solidFill>
                           <a:latin typeface="Calibri"/>
                         </a:rPr>
-                        <a:t>Rider requests per online hour, by zone</a:t>
+                        <a:t>Rider requests per online hour this week, by zone</a:t>
                       </a:r>
                     </a:p>
                   </a:txBody>

</xml_diff>